<commit_message>
Jugadas en español: contenido (artículos, cursos, materiales accesibles con las jugadas dichas) — en curso
Co-Authored-By: Claude Opus 5.5 <noreply@anthropic.com>
Claude-Session: https://claude.ai/code/session_019kpJgFy6kSQESjpjr1aZo4
</commit_message>
<xml_diff>
--- a/cursos/recursos/desequilibrios-de-material/14-sacrificios-de-calidad-iii.pptx
+++ b/cursos/recursos/desequilibrios-de-material/14-sacrificios-de-calidad-iii.pptx
@@ -5699,7 +5699,7 @@
                 </a:solidFill>
                 <a:latin typeface="Calibri"/>
               </a:rPr>
-              <a:t>29...Ce4! prepara ...Bg7 impidiendo la respuesta f5-f6 de las blancas, y ya busca activamente la ventaja en lugar de conformarse con la igualdad.</a:t>
+              <a:t>29...Ce4! prepara ...Ag7 impidiendo la respuesta f5-f6 de las blancas, y ya busca activamente la ventaja en lugar de conformarse con la igualdad.</a:t>
             </a:r>
           </a:p>
         </p:txBody>
@@ -5983,7 +5983,7 @@
                 </a:solidFill>
                 <a:latin typeface="Calibri"/>
               </a:rPr>
-              <a:t>Solución: 34…Re7!</a:t>
+              <a:t>Solución: 34…Te7!</a:t>
             </a:r>
           </a:p>
         </p:txBody>

</xml_diff>